<commit_message>
Slide 7: add AP-affinity alone (no model) result
</commit_message>
<xml_diff>
--- a/presentation/T084_Phase1_Slides.pptx
+++ b/presentation/T084_Phase1_Slides.pptx
@@ -1213,6 +1213,11 @@
           <a:p>
             <a:r>
               <a:t>- We still keep them: the three sets are nested and the full set scored best (we did not test rssi plus AP-affinity alone).</a:t>
+            </a:r>
+          </a:p>
+          <a:p>
+            <a:r>
+              <a:t>- Even alone, with no model, AP-affinity gets 99.9% of test buildings right and a 14.20 m mean 2D error (notebook 02).</a:t>
             </a:r>
           </a:p>
         </p:txBody>
@@ -12164,7 +12169,7 @@
         <p:spPr>
           <a:xfrm>
             <a:off x="7269480" y="2057400"/>
-            <a:ext cx="4370832" cy="2103120"/>
+            <a:ext cx="4370832" cy="1965960"/>
           </a:xfrm>
           <a:prstGeom prst="roundRect">
             <a:avLst>
@@ -12296,7 +12301,7 @@
         <p:spPr>
           <a:xfrm>
             <a:off x="7452360" y="3154680"/>
-            <a:ext cx="4005072" cy="914399"/>
+            <a:ext cx="4005072" cy="777240"/>
           </a:xfrm>
           <a:prstGeom prst="rect">
             <a:avLst/>
@@ -12337,8 +12342,8 @@
         </p:nvSpPr>
         <p:spPr>
           <a:xfrm>
-            <a:off x="7269480" y="4343400"/>
-            <a:ext cx="4370832" cy="1828800"/>
+            <a:off x="7269480" y="4160520"/>
+            <a:ext cx="4370832" cy="1737360"/>
           </a:xfrm>
           <a:prstGeom prst="roundRect">
             <a:avLst>
@@ -12385,7 +12390,7 @@
         </p:nvSpPr>
         <p:spPr>
           <a:xfrm>
-            <a:off x="7452360" y="4489704"/>
+            <a:off x="7452360" y="4306824"/>
             <a:ext cx="4005072" cy="365760"/>
           </a:xfrm>
           <a:prstGeom prst="rect">
@@ -12427,7 +12432,7 @@
         </p:nvSpPr>
         <p:spPr>
           <a:xfrm>
-            <a:off x="7452360" y="4892040"/>
+            <a:off x="7452360" y="4709159"/>
             <a:ext cx="4005072" cy="548640"/>
           </a:xfrm>
           <a:prstGeom prst="rect">
@@ -12469,8 +12474,8 @@
         </p:nvSpPr>
         <p:spPr>
           <a:xfrm>
-            <a:off x="7452360" y="5440680"/>
-            <a:ext cx="4005072" cy="640079"/>
+            <a:off x="7452360" y="5257800"/>
+            <a:ext cx="4005072" cy="548639"/>
           </a:xfrm>
           <a:prstGeom prst="rect">
             <a:avLst/>
@@ -12499,6 +12504,48 @@
                 <a:latin typeface="Arial"/>
               </a:rPr>
               <a:t>No gain: CV mean 2D error slightly higher; floor accuracy 78.5% → 78.0%</a:t>
+            </a:r>
+          </a:p>
+        </p:txBody>
+      </p:sp>
+      <p:sp>
+        <p:nvSpPr>
+          <p:cNvPr id="17" name="TextBox 16"/>
+          <p:cNvSpPr txBox="1"/>
+          <p:nvPr/>
+        </p:nvSpPr>
+        <p:spPr>
+          <a:xfrm>
+            <a:off x="7269480" y="5943600"/>
+            <a:ext cx="4370832" cy="365760"/>
+          </a:xfrm>
+          <a:prstGeom prst="rect">
+            <a:avLst/>
+          </a:prstGeom>
+          <a:noFill/>
+        </p:spPr>
+        <p:txBody>
+          <a:bodyPr wrap="square" anchor="t" lIns="0" rIns="0" tIns="0" bIns="0">
+            <a:noAutofit/>
+          </a:bodyPr>
+          <a:lstStyle/>
+          <a:p>
+            <a:pPr algn="l">
+              <a:lnSpc>
+                <a:spcPct val="115000"/>
+              </a:lnSpc>
+              <a:spcAft>
+                <a:spcPts val="0"/>
+              </a:spcAft>
+            </a:pPr>
+            <a:r>
+              <a:rPr sz="1500" b="1">
+                <a:solidFill>
+                  <a:srgbClr val="0E7C7B"/>
+                </a:solidFill>
+                <a:latin typeface="Arial"/>
+              </a:rPr>
+              <a:t>Alone, no model: 99.9% building, 14.20 m (test)</a:t>
             </a:r>
           </a:p>
         </p:txBody>

</xml_diff>